<commit_message>
End both demo decks on the thank-you slide
The demos walked the layouts in numeric order, which put the closing slide
at position 10 with six more slides after it — fine as a render check, wrong
as a deck. Move it to the end in web/demo/demo.tsx and in demo_slides(), and
renumber the web deck so the printed page numbers stay 1..16 in order.

Layout numbering is untouched: closing is still L10 and the 1:1 mapping in
conventions.md still holds. In build.py the tuple's first element is the
layout id, not a page number, so the moved append keeps its 10.

Co-Authored-By: Claude Opus 5 <noreply@anthropic.com>
</commit_message>
<xml_diff>
--- a/NCT-Slide-Template-Demo.pptx
+++ b/NCT-Slide-Template-Demo.pptx
@@ -12167,14 +12167,14 @@
             <a:pPr/>
             <a:r>
               <a:rPr lang="th-TH" dirty="0"/>
-              <a:t>ขอบคุณครับ</a:t>
-            </a:r>
-          </a:p>
-        </p:txBody>
-      </p:sp>
-      <p:sp>
-        <p:nvSpPr>
-          <p:cNvPr id="3" name="Contact"/>
+              <a:t>สภาพระบบบัญชีปัจจุบัน</a:t>
+            </a:r>
+          </a:p>
+        </p:txBody>
+      </p:sp>
+      <p:sp>
+        <p:nvSpPr>
+          <p:cNvPr id="3" name="CtxK"/>
           <p:cNvSpPr>
             <a:spLocks noGrp="1"/>
           </p:cNvSpPr>
@@ -12190,21 +12190,164 @@
             <a:pPr/>
             <a:r>
               <a:rPr lang="th-TH" dirty="0"/>
-              <a:t>โทร · 02-XXX-XXXX</a:t>
-            </a:r>
-          </a:p>
+              <a:t>สภาพปัจจุบัน</a:t>
+            </a:r>
+          </a:p>
+        </p:txBody>
+      </p:sp>
+      <p:sp>
+        <p:nvSpPr>
+          <p:cNvPr id="4" name="CtxB"/>
+          <p:cNvSpPr>
+            <a:spLocks noGrp="1"/>
+          </p:cNvSpPr>
+          <p:nvPr>
+            <p:ph type="body" idx="2"/>
+          </p:nvPr>
+        </p:nvSpPr>
+        <p:spPr/>
+        <p:txBody>
+          <a:bodyPr/>
+          <a:lstStyle/>
           <a:p>
             <a:pPr/>
             <a:r>
               <a:rPr lang="th-TH" dirty="0"/>
-              <a:t>อีเมล · contact@nctthai.com</a:t>
+              <a:t>คีย์เอกสารซ้ำสามระบบ ไม่มีจุดตรวจกลาง</a:t>
+            </a:r>
+          </a:p>
+          <a:p>
+            <a:pPr lvl="1"/>
+            <a:r>
+              <a:rPr lang="th-TH" dirty="0"/>
+              <a:t>เอกสารเข้าเฉลี่ย 1,200 ใบต่อเดือน</a:t>
             </a:r>
           </a:p>
           <a:p>
             <a:pPr/>
             <a:r>
               <a:rPr lang="th-TH" dirty="0"/>
-              <a:t>เว็บไซต์ · nctthai.com</a:t>
+              <a:t>ปิดงบล่าช้าเฉลี่ย 6 วันทำการ</a:t>
+            </a:r>
+          </a:p>
+          <a:p>
+            <a:pPr/>
+            <a:r>
+              <a:rPr lang="th-TH" dirty="0"/>
+              <a:t>ไม่มี audit trail ของการแก้ไขรายการ</a:t>
+            </a:r>
+          </a:p>
+        </p:txBody>
+      </p:sp>
+      <p:sp>
+        <p:nvSpPr>
+          <p:cNvPr id="5" name="OutK"/>
+          <p:cNvSpPr>
+            <a:spLocks noGrp="1"/>
+          </p:cNvSpPr>
+          <p:nvPr>
+            <p:ph type="body" idx="3"/>
+          </p:nvPr>
+        </p:nvSpPr>
+        <p:spPr/>
+        <p:txBody>
+          <a:bodyPr/>
+          <a:lstStyle/>
+          <a:p>
+            <a:pPr/>
+            <a:r>
+              <a:rPr lang="th-TH" dirty="0"/>
+              <a:t>สิ่งที่จะเกิดขึ้น</a:t>
+            </a:r>
+          </a:p>
+        </p:txBody>
+      </p:sp>
+      <p:sp>
+        <p:nvSpPr>
+          <p:cNvPr id="6" name="OutB"/>
+          <p:cNvSpPr>
+            <a:spLocks noGrp="1"/>
+          </p:cNvSpPr>
+          <p:nvPr>
+            <p:ph type="body" idx="4"/>
+          </p:nvPr>
+        </p:nvSpPr>
+        <p:spPr/>
+        <p:txBody>
+          <a:bodyPr/>
+          <a:lstStyle/>
+          <a:p>
+            <a:pPr/>
+            <a:r>
+              <a:rPr lang="th-TH" dirty="0"/>
+              <a:t>คีย์จุดเดียว ระบบกระจายต่อให้อัตโนมัติ</a:t>
+            </a:r>
+          </a:p>
+          <a:p>
+            <a:pPr lvl="1"/>
+            <a:r>
+              <a:rPr lang="th-TH" dirty="0"/>
+              <a:t>ลดเวลาคีย์ต่อใบจาก 4 นาที เหลือ 40 วินาที</a:t>
+            </a:r>
+          </a:p>
+          <a:p>
+            <a:pPr/>
+            <a:r>
+              <a:rPr lang="th-TH" dirty="0"/>
+              <a:t>ปิดงบภายใน 2 วันทำการ</a:t>
+            </a:r>
+          </a:p>
+          <a:p>
+            <a:pPr/>
+            <a:r>
+              <a:rPr lang="th-TH" dirty="0"/>
+              <a:t>บันทึกทุกการแก้ไขพร้อมผู้ทำและเวลา</a:t>
+            </a:r>
+          </a:p>
+        </p:txBody>
+      </p:sp>
+      <p:sp>
+        <p:nvSpPr>
+          <p:cNvPr id="7" name="TkL"/>
+          <p:cNvSpPr>
+            <a:spLocks noGrp="1"/>
+          </p:cNvSpPr>
+          <p:nvPr>
+            <p:ph type="body" idx="5"/>
+          </p:nvPr>
+        </p:nvSpPr>
+        <p:spPr/>
+        <p:txBody>
+          <a:bodyPr/>
+          <a:lstStyle/>
+          <a:p>
+            <a:pPr/>
+            <a:r>
+              <a:rPr lang="th-TH" dirty="0"/>
+              <a:t>สรุป</a:t>
+            </a:r>
+          </a:p>
+        </p:txBody>
+      </p:sp>
+      <p:sp>
+        <p:nvSpPr>
+          <p:cNvPr id="8" name="TkC"/>
+          <p:cNvSpPr>
+            <a:spLocks noGrp="1"/>
+          </p:cNvSpPr>
+          <p:nvPr>
+            <p:ph type="body" idx="6"/>
+          </p:nvPr>
+        </p:nvSpPr>
+        <p:spPr/>
+        <p:txBody>
+          <a:bodyPr/>
+          <a:lstStyle/>
+          <a:p>
+            <a:pPr/>
+            <a:r>
+              <a:rPr lang="th-TH" dirty="0"/>
+              <a:t>ปัญหาหลักคือการคีย์ซ้ำ ไม่ใช่จำนวนเอกสาร</a:t>
             </a:r>
           </a:p>
         </p:txBody>
@@ -12252,14 +12395,14 @@
             <a:pPr/>
             <a:r>
               <a:rPr lang="th-TH" dirty="0"/>
-              <a:t>สภาพระบบบัญชีปัจจุบัน</a:t>
-            </a:r>
-          </a:p>
-        </p:txBody>
-      </p:sp>
-      <p:sp>
-        <p:nvSpPr>
-          <p:cNvPr id="3" name="CtxK"/>
+              <a:t>สี่ผลลัพธ์ที่ข้อเสนอนี้ให้</a:t>
+            </a:r>
+          </a:p>
+        </p:txBody>
+      </p:sp>
+      <p:sp>
+        <p:nvSpPr>
+          <p:cNvPr id="3" name="N0"/>
           <p:cNvSpPr>
             <a:spLocks noGrp="1"/>
           </p:cNvSpPr>
@@ -12275,14 +12418,14 @@
             <a:pPr/>
             <a:r>
               <a:rPr lang="th-TH" dirty="0"/>
-              <a:t>สภาพปัจจุบัน</a:t>
-            </a:r>
-          </a:p>
-        </p:txBody>
-      </p:sp>
-      <p:sp>
-        <p:nvSpPr>
-          <p:cNvPr id="4" name="CtxB"/>
+              <a:t>01</a:t>
+            </a:r>
+          </a:p>
+        </p:txBody>
+      </p:sp>
+      <p:sp>
+        <p:nvSpPr>
+          <p:cNvPr id="4" name="H0"/>
           <p:cNvSpPr>
             <a:spLocks noGrp="1"/>
           </p:cNvSpPr>
@@ -12298,40 +12441,88 @@
             <a:pPr/>
             <a:r>
               <a:rPr lang="th-TH" dirty="0"/>
-              <a:t>คีย์เอกสารซ้ำสามระบบ ไม่มีจุดตรวจกลาง</a:t>
-            </a:r>
-          </a:p>
-          <a:p>
-            <a:pPr lvl="1"/>
+              <a:t>ลดงานคีย์ซ้ำ</a:t>
+            </a:r>
+          </a:p>
+        </p:txBody>
+      </p:sp>
+      <p:sp>
+        <p:nvSpPr>
+          <p:cNvPr id="5" name="B0"/>
+          <p:cNvSpPr>
+            <a:spLocks noGrp="1"/>
+          </p:cNvSpPr>
+          <p:nvPr>
+            <p:ph type="body" idx="3"/>
+          </p:nvPr>
+        </p:nvSpPr>
+        <p:spPr/>
+        <p:txBody>
+          <a:bodyPr/>
+          <a:lstStyle/>
+          <a:p>
+            <a:pPr/>
             <a:r>
               <a:rPr lang="th-TH" dirty="0"/>
-              <a:t>เอกสารเข้าเฉลี่ย 1,200 ใบต่อเดือน</a:t>
-            </a:r>
-          </a:p>
+              <a:t>รับเอกสารเข้าระบบเดียว แล้วกระจายต่อให้ทุกปลายทางอัตโนมัติ</a:t>
+            </a:r>
+          </a:p>
+        </p:txBody>
+      </p:sp>
+      <p:sp>
+        <p:nvSpPr>
+          <p:cNvPr id="6" name="N1"/>
+          <p:cNvSpPr>
+            <a:spLocks noGrp="1"/>
+          </p:cNvSpPr>
+          <p:nvPr>
+            <p:ph type="body" idx="4"/>
+          </p:nvPr>
+        </p:nvSpPr>
+        <p:spPr/>
+        <p:txBody>
+          <a:bodyPr/>
+          <a:lstStyle/>
           <a:p>
             <a:pPr/>
             <a:r>
               <a:rPr lang="th-TH" dirty="0"/>
-              <a:t>ปิดงบล่าช้าเฉลี่ย 6 วันทำการ</a:t>
-            </a:r>
-          </a:p>
+              <a:t>02</a:t>
+            </a:r>
+          </a:p>
+        </p:txBody>
+      </p:sp>
+      <p:sp>
+        <p:nvSpPr>
+          <p:cNvPr id="7" name="H1"/>
+          <p:cNvSpPr>
+            <a:spLocks noGrp="1"/>
+          </p:cNvSpPr>
+          <p:nvPr>
+            <p:ph type="body" idx="5"/>
+          </p:nvPr>
+        </p:nvSpPr>
+        <p:spPr/>
+        <p:txBody>
+          <a:bodyPr/>
+          <a:lstStyle/>
           <a:p>
             <a:pPr/>
             <a:r>
               <a:rPr lang="th-TH" dirty="0"/>
-              <a:t>ไม่มี audit trail ของการแก้ไขรายการ</a:t>
-            </a:r>
-          </a:p>
-        </p:txBody>
-      </p:sp>
-      <p:sp>
-        <p:nvSpPr>
-          <p:cNvPr id="5" name="OutK"/>
-          <p:cNvSpPr>
-            <a:spLocks noGrp="1"/>
-          </p:cNvSpPr>
-          <p:nvPr>
-            <p:ph type="body" idx="3"/>
+              <a:t>ตรวจสอบได้</a:t>
+            </a:r>
+          </a:p>
+        </p:txBody>
+      </p:sp>
+      <p:sp>
+        <p:nvSpPr>
+          <p:cNvPr id="8" name="B1"/>
+          <p:cNvSpPr>
+            <a:spLocks noGrp="1"/>
+          </p:cNvSpPr>
+          <p:nvPr>
+            <p:ph type="body" idx="6"/>
           </p:nvPr>
         </p:nvSpPr>
         <p:spPr/>
@@ -12342,19 +12533,19 @@
             <a:pPr/>
             <a:r>
               <a:rPr lang="th-TH" dirty="0"/>
-              <a:t>สิ่งที่จะเกิดขึ้น</a:t>
-            </a:r>
-          </a:p>
-        </p:txBody>
-      </p:sp>
-      <p:sp>
-        <p:nvSpPr>
-          <p:cNvPr id="6" name="OutB"/>
-          <p:cNvSpPr>
-            <a:spLocks noGrp="1"/>
-          </p:cNvSpPr>
-          <p:nvPr>
-            <p:ph type="body" idx="4"/>
+              <a:t>ทุกรายการมี audit trail ผู้ทำ เวลา และค่าก่อนหลัง</a:t>
+            </a:r>
+          </a:p>
+        </p:txBody>
+      </p:sp>
+      <p:sp>
+        <p:nvSpPr>
+          <p:cNvPr id="9" name="N2"/>
+          <p:cNvSpPr>
+            <a:spLocks noGrp="1"/>
+          </p:cNvSpPr>
+          <p:nvPr>
+            <p:ph type="body" idx="7"/>
           </p:nvPr>
         </p:nvSpPr>
         <p:spPr/>
@@ -12365,40 +12556,134 @@
             <a:pPr/>
             <a:r>
               <a:rPr lang="th-TH" dirty="0"/>
-              <a:t>คีย์จุดเดียว ระบบกระจายต่อให้อัตโนมัติ</a:t>
-            </a:r>
-          </a:p>
-          <a:p>
-            <a:pPr lvl="1"/>
+              <a:t>03</a:t>
+            </a:r>
+          </a:p>
+        </p:txBody>
+      </p:sp>
+      <p:sp>
+        <p:nvSpPr>
+          <p:cNvPr id="10" name="H2"/>
+          <p:cNvSpPr>
+            <a:spLocks noGrp="1"/>
+          </p:cNvSpPr>
+          <p:nvPr>
+            <p:ph type="body" idx="8"/>
+          </p:nvPr>
+        </p:nvSpPr>
+        <p:spPr/>
+        <p:txBody>
+          <a:bodyPr/>
+          <a:lstStyle/>
+          <a:p>
+            <a:pPr/>
             <a:r>
               <a:rPr lang="th-TH" dirty="0"/>
-              <a:t>ลดเวลาคีย์ต่อใบจาก 4 นาที เหลือ 40 วินาที</a:t>
-            </a:r>
-          </a:p>
+              <a:t>ปิดงบเร็วขึ้น</a:t>
+            </a:r>
+          </a:p>
+        </p:txBody>
+      </p:sp>
+      <p:sp>
+        <p:nvSpPr>
+          <p:cNvPr id="11" name="B2"/>
+          <p:cNvSpPr>
+            <a:spLocks noGrp="1"/>
+          </p:cNvSpPr>
+          <p:nvPr>
+            <p:ph type="body" idx="9"/>
+          </p:nvPr>
+        </p:nvSpPr>
+        <p:spPr/>
+        <p:txBody>
+          <a:bodyPr/>
+          <a:lstStyle/>
           <a:p>
             <a:pPr/>
             <a:r>
               <a:rPr lang="th-TH" dirty="0"/>
-              <a:t>ปิดงบภายใน 2 วันทำการ</a:t>
-            </a:r>
-          </a:p>
+              <a:t>กระทบยอดอัตโนมัติรายวัน ไม่ต้องรอสิ้นเดือน</a:t>
+            </a:r>
+          </a:p>
+        </p:txBody>
+      </p:sp>
+      <p:sp>
+        <p:nvSpPr>
+          <p:cNvPr id="12" name="N3"/>
+          <p:cNvSpPr>
+            <a:spLocks noGrp="1"/>
+          </p:cNvSpPr>
+          <p:nvPr>
+            <p:ph type="body" idx="10"/>
+          </p:nvPr>
+        </p:nvSpPr>
+        <p:spPr/>
+        <p:txBody>
+          <a:bodyPr/>
+          <a:lstStyle/>
           <a:p>
             <a:pPr/>
             <a:r>
               <a:rPr lang="th-TH" dirty="0"/>
-              <a:t>บันทึกทุกการแก้ไขพร้อมผู้ทำและเวลา</a:t>
-            </a:r>
-          </a:p>
-        </p:txBody>
-      </p:sp>
-      <p:sp>
-        <p:nvSpPr>
-          <p:cNvPr id="7" name="TkL"/>
-          <p:cNvSpPr>
-            <a:spLocks noGrp="1"/>
-          </p:cNvSpPr>
-          <p:nvPr>
-            <p:ph type="body" idx="5"/>
+              <a:t>04</a:t>
+            </a:r>
+          </a:p>
+        </p:txBody>
+      </p:sp>
+      <p:sp>
+        <p:nvSpPr>
+          <p:cNvPr id="13" name="H3"/>
+          <p:cNvSpPr>
+            <a:spLocks noGrp="1"/>
+          </p:cNvSpPr>
+          <p:nvPr>
+            <p:ph type="body" idx="11"/>
+          </p:nvPr>
+        </p:nvSpPr>
+        <p:spPr/>
+        <p:txBody>
+          <a:bodyPr/>
+          <a:lstStyle/>
+          <a:p>
+            <a:pPr/>
+            <a:r>
+              <a:rPr lang="th-TH" dirty="0"/>
+              <a:t>ขยายต่อได้</a:t>
+            </a:r>
+          </a:p>
+        </p:txBody>
+      </p:sp>
+      <p:sp>
+        <p:nvSpPr>
+          <p:cNvPr id="14" name="B3"/>
+          <p:cNvSpPr>
+            <a:spLocks noGrp="1"/>
+          </p:cNvSpPr>
+          <p:nvPr>
+            <p:ph type="body" idx="12"/>
+          </p:nvPr>
+        </p:nvSpPr>
+        <p:spPr/>
+        <p:txBody>
+          <a:bodyPr/>
+          <a:lstStyle/>
+          <a:p>
+            <a:pPr/>
+            <a:r>
+              <a:rPr lang="th-TH" dirty="0"/>
+              <a:t>เพิ่มกระบวนการใหม่โดยไม่แก้ของเดิม</a:t>
+            </a:r>
+          </a:p>
+        </p:txBody>
+      </p:sp>
+      <p:sp>
+        <p:nvSpPr>
+          <p:cNvPr id="15" name="BL"/>
+          <p:cNvSpPr>
+            <a:spLocks noGrp="1"/>
+          </p:cNvSpPr>
+          <p:nvPr>
+            <p:ph type="body" idx="13"/>
           </p:nvPr>
         </p:nvSpPr>
         <p:spPr/>
@@ -12416,12 +12701,12 @@
       </p:sp>
       <p:sp>
         <p:nvSpPr>
-          <p:cNvPr id="8" name="TkC"/>
-          <p:cNvSpPr>
-            <a:spLocks noGrp="1"/>
-          </p:cNvSpPr>
-          <p:nvPr>
-            <p:ph type="body" idx="6"/>
+          <p:cNvPr id="16" name="BC"/>
+          <p:cNvSpPr>
+            <a:spLocks noGrp="1"/>
+          </p:cNvSpPr>
+          <p:nvPr>
+            <p:ph type="body" idx="14"/>
           </p:nvPr>
         </p:nvSpPr>
         <p:spPr/>
@@ -12432,7 +12717,7 @@
             <a:pPr/>
             <a:r>
               <a:rPr lang="th-TH" dirty="0"/>
-              <a:t>ปัญหาหลักคือการคีย์ซ้ำ ไม่ใช่จำนวนเอกสาร</a:t>
+              <a:t>ทั้งสี่ข้อมาจากการแก้จุดเดียวกัน คือรวมจุดรับเอกสาร</a:t>
             </a:r>
           </a:p>
         </p:txBody>
@@ -12480,14 +12765,14 @@
             <a:pPr/>
             <a:r>
               <a:rPr lang="th-TH" dirty="0"/>
-              <a:t>สี่ผลลัพธ์ที่ข้อเสนอนี้ให้</a:t>
-            </a:r>
-          </a:p>
-        </p:txBody>
-      </p:sp>
-      <p:sp>
-        <p:nvSpPr>
-          <p:cNvPr id="3" name="N0"/>
+              <a:t>กระบวนการที่เสนอ</a:t>
+            </a:r>
+          </a:p>
+        </p:txBody>
+      </p:sp>
+      <p:sp>
+        <p:nvSpPr>
+          <p:cNvPr id="3" name="Sub"/>
           <p:cNvSpPr>
             <a:spLocks noGrp="1"/>
           </p:cNvSpPr>
@@ -12503,14 +12788,14 @@
             <a:pPr/>
             <a:r>
               <a:rPr lang="th-TH" dirty="0"/>
-              <a:t>01</a:t>
-            </a:r>
-          </a:p>
-        </p:txBody>
-      </p:sp>
-      <p:sp>
-        <p:nvSpPr>
-          <p:cNvPr id="4" name="H0"/>
+              <a:t>ห้าขั้นตอน ทำงานต่อเนื่องโดยไม่ต้องคีย์ซ้ำ</a:t>
+            </a:r>
+          </a:p>
+        </p:txBody>
+      </p:sp>
+      <p:sp>
+        <p:nvSpPr>
+          <p:cNvPr id="4" name="C0"/>
           <p:cNvSpPr>
             <a:spLocks noGrp="1"/>
           </p:cNvSpPr>
@@ -12526,14 +12811,14 @@
             <a:pPr/>
             <a:r>
               <a:rPr lang="th-TH" dirty="0"/>
-              <a:t>ลดงานคีย์ซ้ำ</a:t>
-            </a:r>
-          </a:p>
-        </p:txBody>
-      </p:sp>
-      <p:sp>
-        <p:nvSpPr>
-          <p:cNvPr id="5" name="B0"/>
+              <a:t>1</a:t>
+            </a:r>
+          </a:p>
+        </p:txBody>
+      </p:sp>
+      <p:sp>
+        <p:nvSpPr>
+          <p:cNvPr id="5" name="H0"/>
           <p:cNvSpPr>
             <a:spLocks noGrp="1"/>
           </p:cNvSpPr>
@@ -12549,14 +12834,14 @@
             <a:pPr/>
             <a:r>
               <a:rPr lang="th-TH" dirty="0"/>
-              <a:t>รับเอกสารเข้าระบบเดียว แล้วกระจายต่อให้ทุกปลายทางอัตโนมัติ</a:t>
-            </a:r>
-          </a:p>
-        </p:txBody>
-      </p:sp>
-      <p:sp>
-        <p:nvSpPr>
-          <p:cNvPr id="6" name="N1"/>
+              <a:t>รับเอกสาร</a:t>
+            </a:r>
+          </a:p>
+        </p:txBody>
+      </p:sp>
+      <p:sp>
+        <p:nvSpPr>
+          <p:cNvPr id="6" name="B0"/>
           <p:cNvSpPr>
             <a:spLocks noGrp="1"/>
           </p:cNvSpPr>
@@ -12572,14 +12857,14 @@
             <a:pPr/>
             <a:r>
               <a:rPr lang="th-TH" dirty="0"/>
-              <a:t>02</a:t>
-            </a:r>
-          </a:p>
-        </p:txBody>
-      </p:sp>
-      <p:sp>
-        <p:nvSpPr>
-          <p:cNvPr id="7" name="H1"/>
+              <a:t>สแกนหรือรับไฟล์เข้าคิวกลาง</a:t>
+            </a:r>
+          </a:p>
+        </p:txBody>
+      </p:sp>
+      <p:sp>
+        <p:nvSpPr>
+          <p:cNvPr id="7" name="C1"/>
           <p:cNvSpPr>
             <a:spLocks noGrp="1"/>
           </p:cNvSpPr>
@@ -12595,14 +12880,14 @@
             <a:pPr/>
             <a:r>
               <a:rPr lang="th-TH" dirty="0"/>
-              <a:t>ตรวจสอบได้</a:t>
-            </a:r>
-          </a:p>
-        </p:txBody>
-      </p:sp>
-      <p:sp>
-        <p:nvSpPr>
-          <p:cNvPr id="8" name="B1"/>
+              <a:t>2</a:t>
+            </a:r>
+          </a:p>
+        </p:txBody>
+      </p:sp>
+      <p:sp>
+        <p:nvSpPr>
+          <p:cNvPr id="8" name="H1"/>
           <p:cNvSpPr>
             <a:spLocks noGrp="1"/>
           </p:cNvSpPr>
@@ -12618,14 +12903,14 @@
             <a:pPr/>
             <a:r>
               <a:rPr lang="th-TH" dirty="0"/>
-              <a:t>ทุกรายการมี audit trail ผู้ทำ เวลา และค่าก่อนหลัง</a:t>
-            </a:r>
-          </a:p>
-        </p:txBody>
-      </p:sp>
-      <p:sp>
-        <p:nvSpPr>
-          <p:cNvPr id="9" name="N2"/>
+              <a:t>อ่านข้อมูล</a:t>
+            </a:r>
+          </a:p>
+        </p:txBody>
+      </p:sp>
+      <p:sp>
+        <p:nvSpPr>
+          <p:cNvPr id="9" name="B1"/>
           <p:cNvSpPr>
             <a:spLocks noGrp="1"/>
           </p:cNvSpPr>
@@ -12641,14 +12926,14 @@
             <a:pPr/>
             <a:r>
               <a:rPr lang="th-TH" dirty="0"/>
-              <a:t>03</a:t>
-            </a:r>
-          </a:p>
-        </p:txBody>
-      </p:sp>
-      <p:sp>
-        <p:nvSpPr>
-          <p:cNvPr id="10" name="H2"/>
+              <a:t>ดึงฟิลด์สำคัญ ตรวจกับต้นทาง</a:t>
+            </a:r>
+          </a:p>
+        </p:txBody>
+      </p:sp>
+      <p:sp>
+        <p:nvSpPr>
+          <p:cNvPr id="10" name="C2"/>
           <p:cNvSpPr>
             <a:spLocks noGrp="1"/>
           </p:cNvSpPr>
@@ -12664,14 +12949,14 @@
             <a:pPr/>
             <a:r>
               <a:rPr lang="th-TH" dirty="0"/>
-              <a:t>ปิดงบเร็วขึ้น</a:t>
-            </a:r>
-          </a:p>
-        </p:txBody>
-      </p:sp>
-      <p:sp>
-        <p:nvSpPr>
-          <p:cNvPr id="11" name="B2"/>
+              <a:t>3</a:t>
+            </a:r>
+          </a:p>
+        </p:txBody>
+      </p:sp>
+      <p:sp>
+        <p:nvSpPr>
+          <p:cNvPr id="11" name="H2"/>
           <p:cNvSpPr>
             <a:spLocks noGrp="1"/>
           </p:cNvSpPr>
@@ -12687,14 +12972,14 @@
             <a:pPr/>
             <a:r>
               <a:rPr lang="th-TH" dirty="0"/>
-              <a:t>กระทบยอดอัตโนมัติรายวัน ไม่ต้องรอสิ้นเดือน</a:t>
-            </a:r>
-          </a:p>
-        </p:txBody>
-      </p:sp>
-      <p:sp>
-        <p:nvSpPr>
-          <p:cNvPr id="12" name="N3"/>
+              <a:t>ตรวจสอบ</a:t>
+            </a:r>
+          </a:p>
+        </p:txBody>
+      </p:sp>
+      <p:sp>
+        <p:nvSpPr>
+          <p:cNvPr id="12" name="B2"/>
           <p:cNvSpPr>
             <a:spLocks noGrp="1"/>
           </p:cNvSpPr>
@@ -12710,14 +12995,14 @@
             <a:pPr/>
             <a:r>
               <a:rPr lang="th-TH" dirty="0"/>
-              <a:t>04</a:t>
-            </a:r>
-          </a:p>
-        </p:txBody>
-      </p:sp>
-      <p:sp>
-        <p:nvSpPr>
-          <p:cNvPr id="13" name="H3"/>
+              <a:t>กฎธุรกิจและวงเงินอนุมัติ</a:t>
+            </a:r>
+          </a:p>
+        </p:txBody>
+      </p:sp>
+      <p:sp>
+        <p:nvSpPr>
+          <p:cNvPr id="13" name="C3"/>
           <p:cNvSpPr>
             <a:spLocks noGrp="1"/>
           </p:cNvSpPr>
@@ -12733,14 +13018,14 @@
             <a:pPr/>
             <a:r>
               <a:rPr lang="th-TH" dirty="0"/>
-              <a:t>ขยายต่อได้</a:t>
-            </a:r>
-          </a:p>
-        </p:txBody>
-      </p:sp>
-      <p:sp>
-        <p:nvSpPr>
-          <p:cNvPr id="14" name="B3"/>
+              <a:t>4</a:t>
+            </a:r>
+          </a:p>
+        </p:txBody>
+      </p:sp>
+      <p:sp>
+        <p:nvSpPr>
+          <p:cNvPr id="14" name="H3"/>
           <p:cNvSpPr>
             <a:spLocks noGrp="1"/>
           </p:cNvSpPr>
@@ -12756,14 +13041,14 @@
             <a:pPr/>
             <a:r>
               <a:rPr lang="th-TH" dirty="0"/>
-              <a:t>เพิ่มกระบวนการใหม่โดยไม่แก้ของเดิม</a:t>
-            </a:r>
-          </a:p>
-        </p:txBody>
-      </p:sp>
-      <p:sp>
-        <p:nvSpPr>
-          <p:cNvPr id="15" name="BL"/>
+              <a:t>บันทึก</a:t>
+            </a:r>
+          </a:p>
+        </p:txBody>
+      </p:sp>
+      <p:sp>
+        <p:nvSpPr>
+          <p:cNvPr id="15" name="B3"/>
           <p:cNvSpPr>
             <a:spLocks noGrp="1"/>
           </p:cNvSpPr>
@@ -12779,14 +13064,14 @@
             <a:pPr/>
             <a:r>
               <a:rPr lang="th-TH" dirty="0"/>
-              <a:t>สรุป</a:t>
-            </a:r>
-          </a:p>
-        </p:txBody>
-      </p:sp>
-      <p:sp>
-        <p:nvSpPr>
-          <p:cNvPr id="16" name="BC"/>
+              <a:t>ลงระบบบัญชีพร้อม audit trail</a:t>
+            </a:r>
+          </a:p>
+        </p:txBody>
+      </p:sp>
+      <p:sp>
+        <p:nvSpPr>
+          <p:cNvPr id="16" name="C4"/>
           <p:cNvSpPr>
             <a:spLocks noGrp="1"/>
           </p:cNvSpPr>
@@ -12802,7 +13087,99 @@
             <a:pPr/>
             <a:r>
               <a:rPr lang="th-TH" dirty="0"/>
-              <a:t>ทั้งสี่ข้อมาจากการแก้จุดเดียวกัน คือรวมจุดรับเอกสาร</a:t>
+              <a:t>5</a:t>
+            </a:r>
+          </a:p>
+        </p:txBody>
+      </p:sp>
+      <p:sp>
+        <p:nvSpPr>
+          <p:cNvPr id="17" name="H4"/>
+          <p:cNvSpPr>
+            <a:spLocks noGrp="1"/>
+          </p:cNvSpPr>
+          <p:nvPr>
+            <p:ph type="body" idx="15"/>
+          </p:nvPr>
+        </p:nvSpPr>
+        <p:spPr/>
+        <p:txBody>
+          <a:bodyPr/>
+          <a:lstStyle/>
+          <a:p>
+            <a:pPr/>
+            <a:r>
+              <a:rPr lang="th-TH" dirty="0"/>
+              <a:t>กระทบยอด</a:t>
+            </a:r>
+          </a:p>
+        </p:txBody>
+      </p:sp>
+      <p:sp>
+        <p:nvSpPr>
+          <p:cNvPr id="18" name="B4"/>
+          <p:cNvSpPr>
+            <a:spLocks noGrp="1"/>
+          </p:cNvSpPr>
+          <p:nvPr>
+            <p:ph type="body" idx="16"/>
+          </p:nvPr>
+        </p:nvSpPr>
+        <p:spPr/>
+        <p:txBody>
+          <a:bodyPr/>
+          <a:lstStyle/>
+          <a:p>
+            <a:pPr/>
+            <a:r>
+              <a:rPr lang="th-TH" dirty="0"/>
+              <a:t>จับคู่อัตโนมัติ ส่งรายงาน</a:t>
+            </a:r>
+          </a:p>
+        </p:txBody>
+      </p:sp>
+      <p:sp>
+        <p:nvSpPr>
+          <p:cNvPr id="19" name="RL"/>
+          <p:cNvSpPr>
+            <a:spLocks noGrp="1"/>
+          </p:cNvSpPr>
+          <p:nvPr>
+            <p:ph type="body" idx="17"/>
+          </p:nvPr>
+        </p:nvSpPr>
+        <p:spPr/>
+        <p:txBody>
+          <a:bodyPr/>
+          <a:lstStyle/>
+          <a:p>
+            <a:pPr/>
+            <a:r>
+              <a:rPr lang="th-TH" dirty="0"/>
+              <a:t>ผลลัพธ์</a:t>
+            </a:r>
+          </a:p>
+        </p:txBody>
+      </p:sp>
+      <p:sp>
+        <p:nvSpPr>
+          <p:cNvPr id="20" name="RC"/>
+          <p:cNvSpPr>
+            <a:spLocks noGrp="1"/>
+          </p:cNvSpPr>
+          <p:nvPr>
+            <p:ph type="body" idx="18"/>
+          </p:nvPr>
+        </p:nvSpPr>
+        <p:spPr/>
+        <p:txBody>
+          <a:bodyPr/>
+          <a:lstStyle/>
+          <a:p>
+            <a:pPr/>
+            <a:r>
+              <a:rPr lang="th-TH" dirty="0"/>
+              <a:t>เอกสารหนึ่งใบผ่านครบห้าขั้นโดยไม่มีการคีย์ซ้ำเลย</a:t>
             </a:r>
           </a:p>
         </p:txBody>
@@ -12850,7 +13227,7 @@
             <a:pPr/>
             <a:r>
               <a:rPr lang="th-TH" dirty="0"/>
-              <a:t>กระบวนการที่เสนอ</a:t>
+              <a:t>ภาพรวมสถาปัตยกรรมระบบ</a:t>
             </a:r>
           </a:p>
         </p:txBody>
@@ -12873,14 +13250,14 @@
             <a:pPr/>
             <a:r>
               <a:rPr lang="th-TH" dirty="0"/>
-              <a:t>ห้าขั้นตอน ทำงานต่อเนื่องโดยไม่ต้องคีย์ซ้ำ</a:t>
-            </a:r>
-          </a:p>
-        </p:txBody>
-      </p:sp>
-      <p:sp>
-        <p:nvSpPr>
-          <p:cNvPr id="4" name="C0"/>
+              <a:t>ตัวอย่างการใช้ชุดชิ้นส่วนมาตรฐานตาม v2 §14</a:t>
+            </a:r>
+          </a:p>
+        </p:txBody>
+      </p:sp>
+      <p:sp>
+        <p:nvSpPr>
+          <p:cNvPr id="4" name="Leg"/>
           <p:cNvSpPr>
             <a:spLocks noGrp="1"/>
           </p:cNvSpPr>
@@ -12896,375 +13273,410 @@
             <a:pPr/>
             <a:r>
               <a:rPr lang="th-TH" dirty="0"/>
-              <a:t>1</a:t>
-            </a:r>
-          </a:p>
-        </p:txBody>
-      </p:sp>
-      <p:sp>
-        <p:nvSpPr>
-          <p:cNvPr id="5" name="H0"/>
-          <p:cNvSpPr>
-            <a:spLocks noGrp="1"/>
-          </p:cNvSpPr>
-          <p:nvPr>
-            <p:ph type="body" idx="3"/>
-          </p:nvPr>
-        </p:nvSpPr>
-        <p:spPr/>
+              <a:t>กล่องทึบ = ระบบที่มีอยู่  ·  กล่องมีสีหมวด = ส่วนที่เพิ่ม  ·  เส้นทึบ = ข้อมูลไหลอัตโนมัติ</a:t>
+            </a:r>
+          </a:p>
+        </p:txBody>
+      </p:sp>
+      <p:sp>
+        <p:nvSpPr>
+          <p:cNvPr id="10" name="Group Frame"/>
+          <p:cNvSpPr/>
+          <p:nvPr/>
+        </p:nvSpPr>
+        <p:spPr>
+          <a:xfrm>
+            <a:off x="3657600" y="2560320"/>
+            <a:ext cx="5074920" cy="1554480"/>
+          </a:xfrm>
+          <a:prstGeom prst="rect">
+            <a:avLst/>
+          </a:prstGeom>
+          <a:noFill/>
+          <a:ln w="12700">
+            <a:solidFill>
+              <a:srgbClr val="E5E5E5"/>
+            </a:solidFill>
+            <a:prstDash val="dash"/>
+          </a:ln>
+        </p:spPr>
         <p:txBody>
           <a:bodyPr/>
           <a:lstStyle/>
           <a:p>
-            <a:pPr/>
-            <a:r>
-              <a:rPr lang="th-TH" dirty="0"/>
-              <a:t>รับเอกสาร</a:t>
-            </a:r>
-          </a:p>
-        </p:txBody>
-      </p:sp>
-      <p:sp>
-        <p:nvSpPr>
-          <p:cNvPr id="6" name="B0"/>
-          <p:cNvSpPr>
-            <a:spLocks noGrp="1"/>
-          </p:cNvSpPr>
-          <p:nvPr>
-            <p:ph type="body" idx="4"/>
-          </p:nvPr>
-        </p:nvSpPr>
-        <p:spPr/>
+            <a:endParaRPr lang="th-TH"/>
+          </a:p>
+        </p:txBody>
+      </p:sp>
+      <p:sp>
+        <p:nvSpPr>
+          <p:cNvPr id="11" name="Group Label"/>
+          <p:cNvSpPr/>
+          <p:nvPr/>
+        </p:nvSpPr>
+        <p:spPr>
+          <a:xfrm>
+            <a:off x="3749040" y="2606040"/>
+            <a:ext cx="3200400" cy="274320"/>
+          </a:xfrm>
+          <a:prstGeom prst="rect">
+            <a:avLst/>
+          </a:prstGeom>
+          <a:noFill/>
+          <a:ln>
+            <a:noFill/>
+          </a:ln>
+        </p:spPr>
+        <p:txBody>
+          <a:bodyPr wrap="square" anchor="ctr" lIns="0" tIns="0" rIns="0" bIns="0" rtlCol="0"/>
+          <a:lstStyle/>
+          <a:p>
+            <a:pPr algn="l" marL="0" indent="0">
+              <a:lnSpc>
+                <a:spcPct val="100000"/>
+              </a:lnSpc>
+              <a:buNone/>
+            </a:pPr>
+            <a:r>
+              <a:rPr lang="th-TH" sz="1200" b="1" spc="120" dirty="0">
+                <a:solidFill>
+                  <a:srgbClr val="A4A4A4"/>
+                </a:solidFill>
+                <a:latin typeface="+mn-lt"/>
+                <a:ea typeface="+mn-ea"/>
+                <a:cs typeface="+mn-cs"/>
+              </a:rPr>
+              <a:t>ส่วนที่เพิ่มใหม่</a:t>
+            </a:r>
+          </a:p>
+        </p:txBody>
+      </p:sp>
+      <p:sp>
+        <p:nvSpPr>
+          <p:cNvPr id="12" name="Box 1"/>
+          <p:cNvSpPr/>
+          <p:nvPr/>
+        </p:nvSpPr>
+        <p:spPr>
+          <a:xfrm>
+            <a:off x="1143000" y="3017520"/>
+            <a:ext cx="2011680" cy="548640"/>
+          </a:xfrm>
+          <a:prstGeom prst="rect">
+            <a:avLst/>
+          </a:prstGeom>
+          <a:solidFill>
+            <a:srgbClr val="E8F6F5"/>
+          </a:solidFill>
+          <a:ln w="12700">
+            <a:solidFill>
+              <a:srgbClr val="216B7F"/>
+            </a:solidFill>
+          </a:ln>
+        </p:spPr>
+        <p:txBody>
+          <a:bodyPr wrap="square" anchor="ctr" lIns="0" tIns="0" rIns="0" bIns="0" rtlCol="0"/>
+          <a:lstStyle/>
+          <a:p>
+            <a:pPr algn="ctr" marL="0" indent="0">
+              <a:lnSpc>
+                <a:spcPct val="110000"/>
+              </a:lnSpc>
+              <a:buNone/>
+            </a:pPr>
+            <a:r>
+              <a:rPr lang="th-TH" sz="1200" dirty="0">
+                <a:solidFill>
+                  <a:srgbClr val="333333"/>
+                </a:solidFill>
+                <a:latin typeface="+mn-lt"/>
+                <a:ea typeface="+mn-ea"/>
+                <a:cs typeface="+mn-cs"/>
+              </a:rPr>
+              <a:t>ระบบ ERP ปัจจุบัน</a:t>
+            </a:r>
+          </a:p>
+        </p:txBody>
+      </p:sp>
+      <p:sp>
+        <p:nvSpPr>
+          <p:cNvPr id="13" name="Box 2"/>
+          <p:cNvSpPr/>
+          <p:nvPr/>
+        </p:nvSpPr>
+        <p:spPr>
+          <a:xfrm>
+            <a:off x="3840480" y="3017520"/>
+            <a:ext cx="2011680" cy="548640"/>
+          </a:xfrm>
+          <a:prstGeom prst="rect">
+            <a:avLst/>
+          </a:prstGeom>
+          <a:solidFill>
+            <a:srgbClr val="23436D">
+              <a:alpha val="15000"/>
+            </a:srgbClr>
+          </a:solidFill>
+          <a:ln w="12700">
+            <a:solidFill>
+              <a:srgbClr val="23436D"/>
+            </a:solidFill>
+          </a:ln>
+        </p:spPr>
+        <p:txBody>
+          <a:bodyPr wrap="square" anchor="ctr" lIns="0" tIns="0" rIns="0" bIns="0" rtlCol="0"/>
+          <a:lstStyle/>
+          <a:p>
+            <a:pPr algn="ctr" marL="0" indent="0">
+              <a:lnSpc>
+                <a:spcPct val="110000"/>
+              </a:lnSpc>
+              <a:buNone/>
+            </a:pPr>
+            <a:r>
+              <a:rPr lang="th-TH" sz="1200" dirty="0">
+                <a:solidFill>
+                  <a:srgbClr val="333333"/>
+                </a:solidFill>
+                <a:latin typeface="+mn-lt"/>
+                <a:ea typeface="+mn-ea"/>
+                <a:cs typeface="+mn-cs"/>
+              </a:rPr>
+              <a:t>คิวเอกสารกลาง</a:t>
+            </a:r>
+          </a:p>
+        </p:txBody>
+      </p:sp>
+      <p:sp>
+        <p:nvSpPr>
+          <p:cNvPr id="14" name="Box 3"/>
+          <p:cNvSpPr/>
+          <p:nvPr/>
+        </p:nvSpPr>
+        <p:spPr>
+          <a:xfrm>
+            <a:off x="6537960" y="3017520"/>
+            <a:ext cx="2011680" cy="548640"/>
+          </a:xfrm>
+          <a:prstGeom prst="rect">
+            <a:avLst/>
+          </a:prstGeom>
+          <a:solidFill>
+            <a:srgbClr val="216B7F">
+              <a:alpha val="15000"/>
+            </a:srgbClr>
+          </a:solidFill>
+          <a:ln w="12700">
+            <a:solidFill>
+              <a:srgbClr val="216B7F"/>
+            </a:solidFill>
+          </a:ln>
+        </p:spPr>
+        <p:txBody>
+          <a:bodyPr wrap="square" anchor="ctr" lIns="0" tIns="0" rIns="0" bIns="0" rtlCol="0"/>
+          <a:lstStyle/>
+          <a:p>
+            <a:pPr algn="ctr" marL="0" indent="0">
+              <a:lnSpc>
+                <a:spcPct val="110000"/>
+              </a:lnSpc>
+              <a:buNone/>
+            </a:pPr>
+            <a:r>
+              <a:rPr lang="th-TH" sz="1200" dirty="0">
+                <a:solidFill>
+                  <a:srgbClr val="333333"/>
+                </a:solidFill>
+                <a:latin typeface="+mn-lt"/>
+                <a:ea typeface="+mn-ea"/>
+                <a:cs typeface="+mn-cs"/>
+              </a:rPr>
+              <a:t>ตัวตรวจกฎธุรกิจ</a:t>
+            </a:r>
+          </a:p>
+        </p:txBody>
+      </p:sp>
+      <p:sp>
+        <p:nvSpPr>
+          <p:cNvPr id="15" name="Box 4"/>
+          <p:cNvSpPr/>
+          <p:nvPr/>
+        </p:nvSpPr>
+        <p:spPr>
+          <a:xfrm>
+            <a:off x="9235440" y="3017520"/>
+            <a:ext cx="2011680" cy="548640"/>
+          </a:xfrm>
+          <a:prstGeom prst="rect">
+            <a:avLst/>
+          </a:prstGeom>
+          <a:solidFill>
+            <a:srgbClr val="E8F6F5"/>
+          </a:solidFill>
+          <a:ln w="12700">
+            <a:solidFill>
+              <a:srgbClr val="216B7F"/>
+            </a:solidFill>
+          </a:ln>
+        </p:spPr>
+        <p:txBody>
+          <a:bodyPr wrap="square" anchor="ctr" lIns="0" tIns="0" rIns="0" bIns="0" rtlCol="0"/>
+          <a:lstStyle/>
+          <a:p>
+            <a:pPr algn="ctr" marL="0" indent="0">
+              <a:lnSpc>
+                <a:spcPct val="110000"/>
+              </a:lnSpc>
+              <a:buNone/>
+            </a:pPr>
+            <a:r>
+              <a:rPr lang="th-TH" sz="1200" dirty="0">
+                <a:solidFill>
+                  <a:srgbClr val="333333"/>
+                </a:solidFill>
+                <a:latin typeface="+mn-lt"/>
+                <a:ea typeface="+mn-ea"/>
+                <a:cs typeface="+mn-cs"/>
+              </a:rPr>
+              <a:t>ระบบบัญชี</a:t>
+            </a:r>
+          </a:p>
+        </p:txBody>
+      </p:sp>
+      <p:sp>
+        <p:nvSpPr>
+          <p:cNvPr id="16" name="Link 1"/>
+          <p:cNvSpPr/>
+          <p:nvPr/>
+        </p:nvSpPr>
+        <p:spPr>
+          <a:xfrm>
+            <a:off x="3268980" y="3291840"/>
+            <a:ext cx="457200" cy="0"/>
+          </a:xfrm>
+          <a:prstGeom prst="line">
+            <a:avLst/>
+          </a:prstGeom>
+          <a:noFill/>
+          <a:ln w="15875" cap="flat">
+            <a:solidFill>
+              <a:srgbClr val="216B7F"/>
+            </a:solidFill>
+            <a:prstDash val="solid"/>
+            <a:tailEnd type="triangle" w="med" len="med"/>
+          </a:ln>
+        </p:spPr>
         <p:txBody>
           <a:bodyPr/>
           <a:lstStyle/>
           <a:p>
-            <a:pPr/>
-            <a:r>
-              <a:rPr lang="th-TH" dirty="0"/>
-              <a:t>สแกนหรือรับไฟล์เข้าคิวกลาง</a:t>
-            </a:r>
-          </a:p>
-        </p:txBody>
-      </p:sp>
-      <p:sp>
-        <p:nvSpPr>
-          <p:cNvPr id="7" name="C1"/>
-          <p:cNvSpPr>
-            <a:spLocks noGrp="1"/>
-          </p:cNvSpPr>
-          <p:nvPr>
-            <p:ph type="body" idx="5"/>
-          </p:nvPr>
-        </p:nvSpPr>
-        <p:spPr/>
+            <a:endParaRPr lang="th-TH"/>
+          </a:p>
+        </p:txBody>
+      </p:sp>
+      <p:sp>
+        <p:nvSpPr>
+          <p:cNvPr id="17" name="Link 2"/>
+          <p:cNvSpPr/>
+          <p:nvPr/>
+        </p:nvSpPr>
+        <p:spPr>
+          <a:xfrm>
+            <a:off x="5966460" y="3291840"/>
+            <a:ext cx="457200" cy="0"/>
+          </a:xfrm>
+          <a:prstGeom prst="line">
+            <a:avLst/>
+          </a:prstGeom>
+          <a:noFill/>
+          <a:ln w="15875" cap="flat">
+            <a:solidFill>
+              <a:srgbClr val="216B7F"/>
+            </a:solidFill>
+            <a:prstDash val="solid"/>
+            <a:tailEnd type="triangle" w="med" len="med"/>
+          </a:ln>
+        </p:spPr>
         <p:txBody>
           <a:bodyPr/>
           <a:lstStyle/>
           <a:p>
-            <a:pPr/>
-            <a:r>
-              <a:rPr lang="th-TH" dirty="0"/>
-              <a:t>2</a:t>
-            </a:r>
-          </a:p>
-        </p:txBody>
-      </p:sp>
-      <p:sp>
-        <p:nvSpPr>
-          <p:cNvPr id="8" name="H1"/>
-          <p:cNvSpPr>
-            <a:spLocks noGrp="1"/>
-          </p:cNvSpPr>
-          <p:nvPr>
-            <p:ph type="body" idx="6"/>
-          </p:nvPr>
-        </p:nvSpPr>
-        <p:spPr/>
+            <a:endParaRPr lang="th-TH"/>
+          </a:p>
+        </p:txBody>
+      </p:sp>
+      <p:sp>
+        <p:nvSpPr>
+          <p:cNvPr id="18" name="Link 3"/>
+          <p:cNvSpPr/>
+          <p:nvPr/>
+        </p:nvSpPr>
+        <p:spPr>
+          <a:xfrm>
+            <a:off x="8663940" y="3291840"/>
+            <a:ext cx="457200" cy="0"/>
+          </a:xfrm>
+          <a:prstGeom prst="line">
+            <a:avLst/>
+          </a:prstGeom>
+          <a:noFill/>
+          <a:ln w="15875" cap="flat">
+            <a:solidFill>
+              <a:srgbClr val="216B7F"/>
+            </a:solidFill>
+            <a:prstDash val="solid"/>
+            <a:tailEnd type="triangle" w="med" len="med"/>
+          </a:ln>
+        </p:spPr>
         <p:txBody>
           <a:bodyPr/>
           <a:lstStyle/>
           <a:p>
-            <a:pPr/>
-            <a:r>
-              <a:rPr lang="th-TH" dirty="0"/>
-              <a:t>อ่านข้อมูล</a:t>
-            </a:r>
-          </a:p>
-        </p:txBody>
-      </p:sp>
-      <p:sp>
-        <p:nvSpPr>
-          <p:cNvPr id="9" name="B1"/>
-          <p:cNvSpPr>
-            <a:spLocks noGrp="1"/>
-          </p:cNvSpPr>
-          <p:nvPr>
-            <p:ph type="body" idx="7"/>
-          </p:nvPr>
-        </p:nvSpPr>
-        <p:spPr/>
-        <p:txBody>
-          <a:bodyPr/>
-          <a:lstStyle/>
-          <a:p>
-            <a:pPr/>
-            <a:r>
-              <a:rPr lang="th-TH" dirty="0"/>
-              <a:t>ดึงฟิลด์สำคัญ ตรวจกับต้นทาง</a:t>
-            </a:r>
-          </a:p>
-        </p:txBody>
-      </p:sp>
-      <p:sp>
-        <p:nvSpPr>
-          <p:cNvPr id="10" name="C2"/>
-          <p:cNvSpPr>
-            <a:spLocks noGrp="1"/>
-          </p:cNvSpPr>
-          <p:nvPr>
-            <p:ph type="body" idx="8"/>
-          </p:nvPr>
-        </p:nvSpPr>
-        <p:spPr/>
-        <p:txBody>
-          <a:bodyPr/>
-          <a:lstStyle/>
-          <a:p>
-            <a:pPr/>
-            <a:r>
-              <a:rPr lang="th-TH" dirty="0"/>
-              <a:t>3</a:t>
-            </a:r>
-          </a:p>
-        </p:txBody>
-      </p:sp>
-      <p:sp>
-        <p:nvSpPr>
-          <p:cNvPr id="11" name="H2"/>
-          <p:cNvSpPr>
-            <a:spLocks noGrp="1"/>
-          </p:cNvSpPr>
-          <p:nvPr>
-            <p:ph type="body" idx="9"/>
-          </p:nvPr>
-        </p:nvSpPr>
-        <p:spPr/>
-        <p:txBody>
-          <a:bodyPr/>
-          <a:lstStyle/>
-          <a:p>
-            <a:pPr/>
-            <a:r>
-              <a:rPr lang="th-TH" dirty="0"/>
-              <a:t>ตรวจสอบ</a:t>
-            </a:r>
-          </a:p>
-        </p:txBody>
-      </p:sp>
-      <p:sp>
-        <p:nvSpPr>
-          <p:cNvPr id="12" name="B2"/>
-          <p:cNvSpPr>
-            <a:spLocks noGrp="1"/>
-          </p:cNvSpPr>
-          <p:nvPr>
-            <p:ph type="body" idx="10"/>
-          </p:nvPr>
-        </p:nvSpPr>
-        <p:spPr/>
-        <p:txBody>
-          <a:bodyPr/>
-          <a:lstStyle/>
-          <a:p>
-            <a:pPr/>
-            <a:r>
-              <a:rPr lang="th-TH" dirty="0"/>
-              <a:t>กฎธุรกิจและวงเงินอนุมัติ</a:t>
-            </a:r>
-          </a:p>
-        </p:txBody>
-      </p:sp>
-      <p:sp>
-        <p:nvSpPr>
-          <p:cNvPr id="13" name="C3"/>
-          <p:cNvSpPr>
-            <a:spLocks noGrp="1"/>
-          </p:cNvSpPr>
-          <p:nvPr>
-            <p:ph type="body" idx="11"/>
-          </p:nvPr>
-        </p:nvSpPr>
-        <p:spPr/>
-        <p:txBody>
-          <a:bodyPr/>
-          <a:lstStyle/>
-          <a:p>
-            <a:pPr/>
-            <a:r>
-              <a:rPr lang="th-TH" dirty="0"/>
-              <a:t>4</a:t>
-            </a:r>
-          </a:p>
-        </p:txBody>
-      </p:sp>
-      <p:sp>
-        <p:nvSpPr>
-          <p:cNvPr id="14" name="H3"/>
-          <p:cNvSpPr>
-            <a:spLocks noGrp="1"/>
-          </p:cNvSpPr>
-          <p:nvPr>
-            <p:ph type="body" idx="12"/>
-          </p:nvPr>
-        </p:nvSpPr>
-        <p:spPr/>
-        <p:txBody>
-          <a:bodyPr/>
-          <a:lstStyle/>
-          <a:p>
-            <a:pPr/>
-            <a:r>
-              <a:rPr lang="th-TH" dirty="0"/>
-              <a:t>บันทึก</a:t>
-            </a:r>
-          </a:p>
-        </p:txBody>
-      </p:sp>
-      <p:sp>
-        <p:nvSpPr>
-          <p:cNvPr id="15" name="B3"/>
-          <p:cNvSpPr>
-            <a:spLocks noGrp="1"/>
-          </p:cNvSpPr>
-          <p:nvPr>
-            <p:ph type="body" idx="13"/>
-          </p:nvPr>
-        </p:nvSpPr>
-        <p:spPr/>
-        <p:txBody>
-          <a:bodyPr/>
-          <a:lstStyle/>
-          <a:p>
-            <a:pPr/>
-            <a:r>
-              <a:rPr lang="th-TH" dirty="0"/>
-              <a:t>ลงระบบบัญชีพร้อม audit trail</a:t>
-            </a:r>
-          </a:p>
-        </p:txBody>
-      </p:sp>
-      <p:sp>
-        <p:nvSpPr>
-          <p:cNvPr id="16" name="C4"/>
-          <p:cNvSpPr>
-            <a:spLocks noGrp="1"/>
-          </p:cNvSpPr>
-          <p:nvPr>
-            <p:ph type="body" idx="14"/>
-          </p:nvPr>
-        </p:nvSpPr>
-        <p:spPr/>
-        <p:txBody>
-          <a:bodyPr/>
-          <a:lstStyle/>
-          <a:p>
-            <a:pPr/>
-            <a:r>
-              <a:rPr lang="th-TH" dirty="0"/>
-              <a:t>5</a:t>
-            </a:r>
-          </a:p>
-        </p:txBody>
-      </p:sp>
-      <p:sp>
-        <p:nvSpPr>
-          <p:cNvPr id="17" name="H4"/>
-          <p:cNvSpPr>
-            <a:spLocks noGrp="1"/>
-          </p:cNvSpPr>
-          <p:nvPr>
-            <p:ph type="body" idx="15"/>
-          </p:nvPr>
-        </p:nvSpPr>
-        <p:spPr/>
-        <p:txBody>
-          <a:bodyPr/>
-          <a:lstStyle/>
-          <a:p>
-            <a:pPr/>
-            <a:r>
-              <a:rPr lang="th-TH" dirty="0"/>
-              <a:t>กระทบยอด</a:t>
-            </a:r>
-          </a:p>
-        </p:txBody>
-      </p:sp>
-      <p:sp>
-        <p:nvSpPr>
-          <p:cNvPr id="18" name="B4"/>
-          <p:cNvSpPr>
-            <a:spLocks noGrp="1"/>
-          </p:cNvSpPr>
-          <p:nvPr>
-            <p:ph type="body" idx="16"/>
-          </p:nvPr>
-        </p:nvSpPr>
-        <p:spPr/>
-        <p:txBody>
-          <a:bodyPr/>
-          <a:lstStyle/>
-          <a:p>
-            <a:pPr/>
-            <a:r>
-              <a:rPr lang="th-TH" dirty="0"/>
-              <a:t>จับคู่อัตโนมัติ ส่งรายงาน</a:t>
-            </a:r>
-          </a:p>
-        </p:txBody>
-      </p:sp>
-      <p:sp>
-        <p:nvSpPr>
-          <p:cNvPr id="19" name="RL"/>
-          <p:cNvSpPr>
-            <a:spLocks noGrp="1"/>
-          </p:cNvSpPr>
-          <p:nvPr>
-            <p:ph type="body" idx="17"/>
-          </p:nvPr>
-        </p:nvSpPr>
-        <p:spPr/>
-        <p:txBody>
-          <a:bodyPr/>
-          <a:lstStyle/>
-          <a:p>
-            <a:pPr/>
-            <a:r>
-              <a:rPr lang="th-TH" dirty="0"/>
-              <a:t>ผลลัพธ์</a:t>
-            </a:r>
-          </a:p>
-        </p:txBody>
-      </p:sp>
-      <p:sp>
-        <p:nvSpPr>
-          <p:cNvPr id="20" name="RC"/>
-          <p:cNvSpPr>
-            <a:spLocks noGrp="1"/>
-          </p:cNvSpPr>
-          <p:nvPr>
-            <p:ph type="body" idx="18"/>
-          </p:nvPr>
-        </p:nvSpPr>
-        <p:spPr/>
-        <p:txBody>
-          <a:bodyPr/>
-          <a:lstStyle/>
-          <a:p>
-            <a:pPr/>
-            <a:r>
-              <a:rPr lang="th-TH" dirty="0"/>
-              <a:t>เอกสารหนึ่งใบผ่านครบห้าขั้นโดยไม่มีการคีย์ซ้ำเลย</a:t>
+            <a:endParaRPr lang="th-TH"/>
+          </a:p>
+        </p:txBody>
+      </p:sp>
+      <p:sp>
+        <p:nvSpPr>
+          <p:cNvPr id="19" name="Edge Label"/>
+          <p:cNvSpPr/>
+          <p:nvPr/>
+        </p:nvSpPr>
+        <p:spPr>
+          <a:xfrm>
+            <a:off x="5806440" y="2743200"/>
+            <a:ext cx="822960" cy="228600"/>
+          </a:xfrm>
+          <a:prstGeom prst="rect">
+            <a:avLst/>
+          </a:prstGeom>
+          <a:solidFill>
+            <a:srgbClr val="FFFFFF"/>
+          </a:solidFill>
+          <a:ln>
+            <a:noFill/>
+          </a:ln>
+        </p:spPr>
+        <p:txBody>
+          <a:bodyPr wrap="square" anchor="ctr" lIns="0" tIns="0" rIns="0" bIns="0" rtlCol="0"/>
+          <a:lstStyle/>
+          <a:p>
+            <a:pPr algn="ctr" marL="0" indent="0">
+              <a:lnSpc>
+                <a:spcPct val="100000"/>
+              </a:lnSpc>
+              <a:buNone/>
+            </a:pPr>
+            <a:r>
+              <a:rPr lang="th-TH" sz="1000" dirty="0">
+                <a:solidFill>
+                  <a:srgbClr val="A4A4A4"/>
+                </a:solidFill>
+                <a:latin typeface="+mn-lt"/>
+                <a:ea typeface="+mn-ea"/>
+                <a:cs typeface="+mn-cs"/>
+              </a:rPr>
+              <a:t>ผ่านกฎ</a:t>
             </a:r>
           </a:p>
         </p:txBody>
@@ -13296,7 +13708,30 @@
       </p:grpSpPr>
       <p:sp>
         <p:nvSpPr>
-          <p:cNvPr id="2" name="Title"/>
+          <p:cNvPr id="2" name="Num"/>
+          <p:cNvSpPr>
+            <a:spLocks noGrp="1"/>
+          </p:cNvSpPr>
+          <p:nvPr>
+            <p:ph type="body" idx="1"/>
+          </p:nvPr>
+        </p:nvSpPr>
+        <p:spPr/>
+        <p:txBody>
+          <a:bodyPr/>
+          <a:lstStyle/>
+          <a:p>
+            <a:pPr/>
+            <a:r>
+              <a:rPr lang="th-TH" dirty="0"/>
+              <a:t>02</a:t>
+            </a:r>
+          </a:p>
+        </p:txBody>
+      </p:sp>
+      <p:sp>
+        <p:nvSpPr>
+          <p:cNvPr id="3" name="Title"/>
           <p:cNvSpPr>
             <a:spLocks noGrp="1"/>
           </p:cNvSpPr>
@@ -13312,19 +13747,19 @@
             <a:pPr/>
             <a:r>
               <a:rPr lang="th-TH" dirty="0"/>
-              <a:t>ภาพรวมสถาปัตยกรรมระบบ</a:t>
-            </a:r>
-          </a:p>
-        </p:txBody>
-      </p:sp>
-      <p:sp>
-        <p:nvSpPr>
-          <p:cNvPr id="3" name="Sub"/>
-          <p:cNvSpPr>
-            <a:spLocks noGrp="1"/>
-          </p:cNvSpPr>
-          <p:nvPr>
-            <p:ph type="body" idx="1"/>
+              <a:t>หัวข้อนำเสนอ</a:t>
+            </a:r>
+          </a:p>
+        </p:txBody>
+      </p:sp>
+      <p:sp>
+        <p:nvSpPr>
+          <p:cNvPr id="4" name="List"/>
+          <p:cNvSpPr>
+            <a:spLocks noGrp="1"/>
+          </p:cNvSpPr>
+          <p:nvPr>
+            <p:ph type="body" idx="2"/>
           </p:nvPr>
         </p:nvSpPr>
         <p:spPr/>
@@ -13335,433 +13770,35 @@
             <a:pPr/>
             <a:r>
               <a:rPr lang="th-TH" dirty="0"/>
-              <a:t>ตัวอย่างการใช้ชุดชิ้นส่วนมาตรฐานตาม v2 §14</a:t>
-            </a:r>
-          </a:p>
-        </p:txBody>
-      </p:sp>
-      <p:sp>
-        <p:nvSpPr>
-          <p:cNvPr id="4" name="Leg"/>
-          <p:cNvSpPr>
-            <a:spLocks noGrp="1"/>
-          </p:cNvSpPr>
-          <p:nvPr>
-            <p:ph type="body" idx="2"/>
-          </p:nvPr>
-        </p:nvSpPr>
-        <p:spPr/>
-        <p:txBody>
-          <a:bodyPr/>
-          <a:lstStyle/>
+              <a:t>บริบทและปัญหาที่พบ</a:t>
+            </a:r>
+          </a:p>
           <a:p>
             <a:pPr/>
             <a:r>
               <a:rPr lang="th-TH" dirty="0"/>
-              <a:t>กล่องทึบ = ระบบที่มีอยู่  ·  กล่องมีสีหมวด = ส่วนที่เพิ่ม  ·  เส้นทึบ = ข้อมูลไหลอัตโนมัติ</a:t>
-            </a:r>
-          </a:p>
-        </p:txBody>
-      </p:sp>
-      <p:sp>
-        <p:nvSpPr>
-          <p:cNvPr id="10" name="Group Frame"/>
-          <p:cNvSpPr/>
-          <p:nvPr/>
-        </p:nvSpPr>
-        <p:spPr>
-          <a:xfrm>
-            <a:off x="3657600" y="2560320"/>
-            <a:ext cx="5074920" cy="1554480"/>
-          </a:xfrm>
-          <a:prstGeom prst="rect">
-            <a:avLst/>
-          </a:prstGeom>
-          <a:noFill/>
-          <a:ln w="12700">
-            <a:solidFill>
-              <a:srgbClr val="E5E5E5"/>
-            </a:solidFill>
-            <a:prstDash val="dash"/>
-          </a:ln>
-        </p:spPr>
-        <p:txBody>
-          <a:bodyPr/>
-          <a:lstStyle/>
-          <a:p>
-            <a:endParaRPr lang="th-TH"/>
-          </a:p>
-        </p:txBody>
-      </p:sp>
-      <p:sp>
-        <p:nvSpPr>
-          <p:cNvPr id="11" name="Group Label"/>
-          <p:cNvSpPr/>
-          <p:nvPr/>
-        </p:nvSpPr>
-        <p:spPr>
-          <a:xfrm>
-            <a:off x="3749040" y="2606040"/>
-            <a:ext cx="3200400" cy="274320"/>
-          </a:xfrm>
-          <a:prstGeom prst="rect">
-            <a:avLst/>
-          </a:prstGeom>
-          <a:noFill/>
-          <a:ln>
-            <a:noFill/>
-          </a:ln>
-        </p:spPr>
-        <p:txBody>
-          <a:bodyPr wrap="square" anchor="ctr" lIns="0" tIns="0" rIns="0" bIns="0" rtlCol="0"/>
-          <a:lstStyle/>
-          <a:p>
-            <a:pPr algn="l" marL="0" indent="0">
-              <a:lnSpc>
-                <a:spcPct val="100000"/>
-              </a:lnSpc>
-              <a:buNone/>
-            </a:pPr>
-            <a:r>
-              <a:rPr lang="th-TH" sz="1200" b="1" spc="120" dirty="0">
-                <a:solidFill>
-                  <a:srgbClr val="A4A4A4"/>
-                </a:solidFill>
-                <a:latin typeface="+mn-lt"/>
-                <a:ea typeface="+mn-ea"/>
-                <a:cs typeface="+mn-cs"/>
-              </a:rPr>
-              <a:t>ส่วนที่เพิ่มใหม่</a:t>
-            </a:r>
-          </a:p>
-        </p:txBody>
-      </p:sp>
-      <p:sp>
-        <p:nvSpPr>
-          <p:cNvPr id="12" name="Box 1"/>
-          <p:cNvSpPr/>
-          <p:nvPr/>
-        </p:nvSpPr>
-        <p:spPr>
-          <a:xfrm>
-            <a:off x="1143000" y="3017520"/>
-            <a:ext cx="2011680" cy="548640"/>
-          </a:xfrm>
-          <a:prstGeom prst="rect">
-            <a:avLst/>
-          </a:prstGeom>
-          <a:solidFill>
-            <a:srgbClr val="E8F6F5"/>
-          </a:solidFill>
-          <a:ln w="12700">
-            <a:solidFill>
-              <a:srgbClr val="216B7F"/>
-            </a:solidFill>
-          </a:ln>
-        </p:spPr>
-        <p:txBody>
-          <a:bodyPr wrap="square" anchor="ctr" lIns="0" tIns="0" rIns="0" bIns="0" rtlCol="0"/>
-          <a:lstStyle/>
-          <a:p>
-            <a:pPr algn="ctr" marL="0" indent="0">
-              <a:lnSpc>
-                <a:spcPct val="110000"/>
-              </a:lnSpc>
-              <a:buNone/>
-            </a:pPr>
-            <a:r>
-              <a:rPr lang="th-TH" sz="1200" dirty="0">
-                <a:solidFill>
-                  <a:srgbClr val="333333"/>
-                </a:solidFill>
-                <a:latin typeface="+mn-lt"/>
-                <a:ea typeface="+mn-ea"/>
-                <a:cs typeface="+mn-cs"/>
-              </a:rPr>
-              <a:t>ระบบ ERP ปัจจุบัน</a:t>
-            </a:r>
-          </a:p>
-        </p:txBody>
-      </p:sp>
-      <p:sp>
-        <p:nvSpPr>
-          <p:cNvPr id="13" name="Box 2"/>
-          <p:cNvSpPr/>
-          <p:nvPr/>
-        </p:nvSpPr>
-        <p:spPr>
-          <a:xfrm>
-            <a:off x="3840480" y="3017520"/>
-            <a:ext cx="2011680" cy="548640"/>
-          </a:xfrm>
-          <a:prstGeom prst="rect">
-            <a:avLst/>
-          </a:prstGeom>
-          <a:solidFill>
-            <a:srgbClr val="23436D">
-              <a:alpha val="15000"/>
-            </a:srgbClr>
-          </a:solidFill>
-          <a:ln w="12700">
-            <a:solidFill>
-              <a:srgbClr val="23436D"/>
-            </a:solidFill>
-          </a:ln>
-        </p:spPr>
-        <p:txBody>
-          <a:bodyPr wrap="square" anchor="ctr" lIns="0" tIns="0" rIns="0" bIns="0" rtlCol="0"/>
-          <a:lstStyle/>
-          <a:p>
-            <a:pPr algn="ctr" marL="0" indent="0">
-              <a:lnSpc>
-                <a:spcPct val="110000"/>
-              </a:lnSpc>
-              <a:buNone/>
-            </a:pPr>
-            <a:r>
-              <a:rPr lang="th-TH" sz="1200" dirty="0">
-                <a:solidFill>
-                  <a:srgbClr val="333333"/>
-                </a:solidFill>
-                <a:latin typeface="+mn-lt"/>
-                <a:ea typeface="+mn-ea"/>
-                <a:cs typeface="+mn-cs"/>
-              </a:rPr>
-              <a:t>คิวเอกสารกลาง</a:t>
-            </a:r>
-          </a:p>
-        </p:txBody>
-      </p:sp>
-      <p:sp>
-        <p:nvSpPr>
-          <p:cNvPr id="14" name="Box 3"/>
-          <p:cNvSpPr/>
-          <p:nvPr/>
-        </p:nvSpPr>
-        <p:spPr>
-          <a:xfrm>
-            <a:off x="6537960" y="3017520"/>
-            <a:ext cx="2011680" cy="548640"/>
-          </a:xfrm>
-          <a:prstGeom prst="rect">
-            <a:avLst/>
-          </a:prstGeom>
-          <a:solidFill>
-            <a:srgbClr val="216B7F">
-              <a:alpha val="15000"/>
-            </a:srgbClr>
-          </a:solidFill>
-          <a:ln w="12700">
-            <a:solidFill>
-              <a:srgbClr val="216B7F"/>
-            </a:solidFill>
-          </a:ln>
-        </p:spPr>
-        <p:txBody>
-          <a:bodyPr wrap="square" anchor="ctr" lIns="0" tIns="0" rIns="0" bIns="0" rtlCol="0"/>
-          <a:lstStyle/>
-          <a:p>
-            <a:pPr algn="ctr" marL="0" indent="0">
-              <a:lnSpc>
-                <a:spcPct val="110000"/>
-              </a:lnSpc>
-              <a:buNone/>
-            </a:pPr>
-            <a:r>
-              <a:rPr lang="th-TH" sz="1200" dirty="0">
-                <a:solidFill>
-                  <a:srgbClr val="333333"/>
-                </a:solidFill>
-                <a:latin typeface="+mn-lt"/>
-                <a:ea typeface="+mn-ea"/>
-                <a:cs typeface="+mn-cs"/>
-              </a:rPr>
-              <a:t>ตัวตรวจกฎธุรกิจ</a:t>
-            </a:r>
-          </a:p>
-        </p:txBody>
-      </p:sp>
-      <p:sp>
-        <p:nvSpPr>
-          <p:cNvPr id="15" name="Box 4"/>
-          <p:cNvSpPr/>
-          <p:nvPr/>
-        </p:nvSpPr>
-        <p:spPr>
-          <a:xfrm>
-            <a:off x="9235440" y="3017520"/>
-            <a:ext cx="2011680" cy="548640"/>
-          </a:xfrm>
-          <a:prstGeom prst="rect">
-            <a:avLst/>
-          </a:prstGeom>
-          <a:solidFill>
-            <a:srgbClr val="E8F6F5"/>
-          </a:solidFill>
-          <a:ln w="12700">
-            <a:solidFill>
-              <a:srgbClr val="216B7F"/>
-            </a:solidFill>
-          </a:ln>
-        </p:spPr>
-        <p:txBody>
-          <a:bodyPr wrap="square" anchor="ctr" lIns="0" tIns="0" rIns="0" bIns="0" rtlCol="0"/>
-          <a:lstStyle/>
-          <a:p>
-            <a:pPr algn="ctr" marL="0" indent="0">
-              <a:lnSpc>
-                <a:spcPct val="110000"/>
-              </a:lnSpc>
-              <a:buNone/>
-            </a:pPr>
-            <a:r>
-              <a:rPr lang="th-TH" sz="1200" dirty="0">
-                <a:solidFill>
-                  <a:srgbClr val="333333"/>
-                </a:solidFill>
-                <a:latin typeface="+mn-lt"/>
-                <a:ea typeface="+mn-ea"/>
-                <a:cs typeface="+mn-cs"/>
-              </a:rPr>
-              <a:t>ระบบบัญชี</a:t>
-            </a:r>
-          </a:p>
-        </p:txBody>
-      </p:sp>
-      <p:sp>
-        <p:nvSpPr>
-          <p:cNvPr id="16" name="Link 1"/>
-          <p:cNvSpPr/>
-          <p:nvPr/>
-        </p:nvSpPr>
-        <p:spPr>
-          <a:xfrm>
-            <a:off x="3268980" y="3291840"/>
-            <a:ext cx="457200" cy="0"/>
-          </a:xfrm>
-          <a:prstGeom prst="line">
-            <a:avLst/>
-          </a:prstGeom>
-          <a:noFill/>
-          <a:ln w="15875" cap="flat">
-            <a:solidFill>
-              <a:srgbClr val="216B7F"/>
-            </a:solidFill>
-            <a:prstDash val="solid"/>
-            <a:tailEnd type="triangle" w="med" len="med"/>
-          </a:ln>
-        </p:spPr>
-        <p:txBody>
-          <a:bodyPr/>
-          <a:lstStyle/>
-          <a:p>
-            <a:endParaRPr lang="th-TH"/>
-          </a:p>
-        </p:txBody>
-      </p:sp>
-      <p:sp>
-        <p:nvSpPr>
-          <p:cNvPr id="17" name="Link 2"/>
-          <p:cNvSpPr/>
-          <p:nvPr/>
-        </p:nvSpPr>
-        <p:spPr>
-          <a:xfrm>
-            <a:off x="5966460" y="3291840"/>
-            <a:ext cx="457200" cy="0"/>
-          </a:xfrm>
-          <a:prstGeom prst="line">
-            <a:avLst/>
-          </a:prstGeom>
-          <a:noFill/>
-          <a:ln w="15875" cap="flat">
-            <a:solidFill>
-              <a:srgbClr val="216B7F"/>
-            </a:solidFill>
-            <a:prstDash val="solid"/>
-            <a:tailEnd type="triangle" w="med" len="med"/>
-          </a:ln>
-        </p:spPr>
-        <p:txBody>
-          <a:bodyPr/>
-          <a:lstStyle/>
-          <a:p>
-            <a:endParaRPr lang="th-TH"/>
-          </a:p>
-        </p:txBody>
-      </p:sp>
-      <p:sp>
-        <p:nvSpPr>
-          <p:cNvPr id="18" name="Link 3"/>
-          <p:cNvSpPr/>
-          <p:nvPr/>
-        </p:nvSpPr>
-        <p:spPr>
-          <a:xfrm>
-            <a:off x="8663940" y="3291840"/>
-            <a:ext cx="457200" cy="0"/>
-          </a:xfrm>
-          <a:prstGeom prst="line">
-            <a:avLst/>
-          </a:prstGeom>
-          <a:noFill/>
-          <a:ln w="15875" cap="flat">
-            <a:solidFill>
-              <a:srgbClr val="216B7F"/>
-            </a:solidFill>
-            <a:prstDash val="solid"/>
-            <a:tailEnd type="triangle" w="med" len="med"/>
-          </a:ln>
-        </p:spPr>
-        <p:txBody>
-          <a:bodyPr/>
-          <a:lstStyle/>
-          <a:p>
-            <a:endParaRPr lang="th-TH"/>
-          </a:p>
-        </p:txBody>
-      </p:sp>
-      <p:sp>
-        <p:nvSpPr>
-          <p:cNvPr id="19" name="Edge Label"/>
-          <p:cNvSpPr/>
-          <p:nvPr/>
-        </p:nvSpPr>
-        <p:spPr>
-          <a:xfrm>
-            <a:off x="5806440" y="2743200"/>
-            <a:ext cx="822960" cy="228600"/>
-          </a:xfrm>
-          <a:prstGeom prst="rect">
-            <a:avLst/>
-          </a:prstGeom>
-          <a:solidFill>
-            <a:srgbClr val="FFFFFF"/>
-          </a:solidFill>
-          <a:ln>
-            <a:noFill/>
-          </a:ln>
-        </p:spPr>
-        <p:txBody>
-          <a:bodyPr wrap="square" anchor="ctr" lIns="0" tIns="0" rIns="0" bIns="0" rtlCol="0"/>
-          <a:lstStyle/>
-          <a:p>
-            <a:pPr algn="ctr" marL="0" indent="0">
-              <a:lnSpc>
-                <a:spcPct val="100000"/>
-              </a:lnSpc>
-              <a:buNone/>
-            </a:pPr>
-            <a:r>
-              <a:rPr lang="th-TH" sz="1000" dirty="0">
-                <a:solidFill>
-                  <a:srgbClr val="A4A4A4"/>
-                </a:solidFill>
-                <a:latin typeface="+mn-lt"/>
-                <a:ea typeface="+mn-ea"/>
-                <a:cs typeface="+mn-cs"/>
-              </a:rPr>
-              <a:t>ผ่านกฎ</a:t>
+              <a:t>วัตถุประสงค์ของโครงการ</a:t>
+            </a:r>
+          </a:p>
+          <a:p>
+            <a:pPr/>
+            <a:r>
+              <a:rPr lang="th-TH" dirty="0"/>
+              <a:t>ขอบเขตงานรายกระบวนการ</a:t>
+            </a:r>
+          </a:p>
+          <a:p>
+            <a:pPr/>
+            <a:r>
+              <a:rPr lang="th-TH" dirty="0"/>
+              <a:t>แผนดำเนินงานและผู้รับผิดชอบ</a:t>
+            </a:r>
+          </a:p>
+          <a:p>
+            <a:pPr/>
+            <a:r>
+              <a:rPr lang="th-TH" dirty="0"/>
+              <a:t>งบประมาณและเงื่อนไข</a:t>
             </a:r>
           </a:p>
         </p:txBody>
@@ -13775,128 +13812,6 @@
 </file>
 
 <file path=ppt/slides/slide15.xml><?xml version="1.0" encoding="utf-8"?>
-<p:sld xmlns:a="http://schemas.openxmlformats.org/drawingml/2006/main" xmlns:r="http://schemas.openxmlformats.org/officeDocument/2006/relationships" xmlns:p="http://schemas.openxmlformats.org/presentationml/2006/main">
-  <p:cSld name="">
-    <p:spTree>
-      <p:nvGrpSpPr>
-        <p:cNvPr id="1" name=""/>
-        <p:cNvGrpSpPr/>
-        <p:nvPr/>
-      </p:nvGrpSpPr>
-      <p:grpSpPr>
-        <a:xfrm>
-          <a:off x="0" y="0"/>
-          <a:ext cx="0" cy="0"/>
-          <a:chOff x="0" y="0"/>
-          <a:chExt cx="0" cy="0"/>
-        </a:xfrm>
-      </p:grpSpPr>
-      <p:sp>
-        <p:nvSpPr>
-          <p:cNvPr id="2" name="Num"/>
-          <p:cNvSpPr>
-            <a:spLocks noGrp="1"/>
-          </p:cNvSpPr>
-          <p:nvPr>
-            <p:ph type="body" idx="1"/>
-          </p:nvPr>
-        </p:nvSpPr>
-        <p:spPr/>
-        <p:txBody>
-          <a:bodyPr/>
-          <a:lstStyle/>
-          <a:p>
-            <a:pPr/>
-            <a:r>
-              <a:rPr lang="th-TH" dirty="0"/>
-              <a:t>02</a:t>
-            </a:r>
-          </a:p>
-        </p:txBody>
-      </p:sp>
-      <p:sp>
-        <p:nvSpPr>
-          <p:cNvPr id="3" name="Title"/>
-          <p:cNvSpPr>
-            <a:spLocks noGrp="1"/>
-          </p:cNvSpPr>
-          <p:nvPr>
-            <p:ph type="title"/>
-          </p:nvPr>
-        </p:nvSpPr>
-        <p:spPr/>
-        <p:txBody>
-          <a:bodyPr/>
-          <a:lstStyle/>
-          <a:p>
-            <a:pPr/>
-            <a:r>
-              <a:rPr lang="th-TH" dirty="0"/>
-              <a:t>หัวข้อนำเสนอ</a:t>
-            </a:r>
-          </a:p>
-        </p:txBody>
-      </p:sp>
-      <p:sp>
-        <p:nvSpPr>
-          <p:cNvPr id="4" name="List"/>
-          <p:cNvSpPr>
-            <a:spLocks noGrp="1"/>
-          </p:cNvSpPr>
-          <p:nvPr>
-            <p:ph type="body" idx="2"/>
-          </p:nvPr>
-        </p:nvSpPr>
-        <p:spPr/>
-        <p:txBody>
-          <a:bodyPr/>
-          <a:lstStyle/>
-          <a:p>
-            <a:pPr/>
-            <a:r>
-              <a:rPr lang="th-TH" dirty="0"/>
-              <a:t>บริบทและปัญหาที่พบ</a:t>
-            </a:r>
-          </a:p>
-          <a:p>
-            <a:pPr/>
-            <a:r>
-              <a:rPr lang="th-TH" dirty="0"/>
-              <a:t>วัตถุประสงค์ของโครงการ</a:t>
-            </a:r>
-          </a:p>
-          <a:p>
-            <a:pPr/>
-            <a:r>
-              <a:rPr lang="th-TH" dirty="0"/>
-              <a:t>ขอบเขตงานรายกระบวนการ</a:t>
-            </a:r>
-          </a:p>
-          <a:p>
-            <a:pPr/>
-            <a:r>
-              <a:rPr lang="th-TH" dirty="0"/>
-              <a:t>แผนดำเนินงานและผู้รับผิดชอบ</a:t>
-            </a:r>
-          </a:p>
-          <a:p>
-            <a:pPr/>
-            <a:r>
-              <a:rPr lang="th-TH" dirty="0"/>
-              <a:t>งบประมาณและเงื่อนไข</a:t>
-            </a:r>
-          </a:p>
-        </p:txBody>
-      </p:sp>
-    </p:spTree>
-  </p:cSld>
-  <p:clrMapOvr>
-    <a:masterClrMapping/>
-  </p:clrMapOvr>
-</p:sld>
-</file>
-
-<file path=ppt/slides/slide16.xml><?xml version="1.0" encoding="utf-8"?>
 <p:sld xmlns:a="http://schemas.openxmlformats.org/drawingml/2006/main" xmlns:r="http://schemas.openxmlformats.org/officeDocument/2006/relationships" xmlns:p="http://schemas.openxmlformats.org/presentationml/2006/main">
   <p:cSld name="">
     <p:spTree>
@@ -15292,6 +15207,91 @@
 </p:sld>
 </file>
 
+<file path=ppt/slides/slide16.xml><?xml version="1.0" encoding="utf-8"?>
+<p:sld xmlns:a="http://schemas.openxmlformats.org/drawingml/2006/main" xmlns:r="http://schemas.openxmlformats.org/officeDocument/2006/relationships" xmlns:p="http://schemas.openxmlformats.org/presentationml/2006/main">
+  <p:cSld name="">
+    <p:spTree>
+      <p:nvGrpSpPr>
+        <p:cNvPr id="1" name=""/>
+        <p:cNvGrpSpPr/>
+        <p:nvPr/>
+      </p:nvGrpSpPr>
+      <p:grpSpPr>
+        <a:xfrm>
+          <a:off x="0" y="0"/>
+          <a:ext cx="0" cy="0"/>
+          <a:chOff x="0" y="0"/>
+          <a:chExt cx="0" cy="0"/>
+        </a:xfrm>
+      </p:grpSpPr>
+      <p:sp>
+        <p:nvSpPr>
+          <p:cNvPr id="2" name="Title"/>
+          <p:cNvSpPr>
+            <a:spLocks noGrp="1"/>
+          </p:cNvSpPr>
+          <p:nvPr>
+            <p:ph type="title"/>
+          </p:nvPr>
+        </p:nvSpPr>
+        <p:spPr/>
+        <p:txBody>
+          <a:bodyPr/>
+          <a:lstStyle/>
+          <a:p>
+            <a:pPr/>
+            <a:r>
+              <a:rPr lang="th-TH" dirty="0"/>
+              <a:t>ขอบคุณครับ</a:t>
+            </a:r>
+          </a:p>
+        </p:txBody>
+      </p:sp>
+      <p:sp>
+        <p:nvSpPr>
+          <p:cNvPr id="3" name="Contact"/>
+          <p:cNvSpPr>
+            <a:spLocks noGrp="1"/>
+          </p:cNvSpPr>
+          <p:nvPr>
+            <p:ph type="body" idx="1"/>
+          </p:nvPr>
+        </p:nvSpPr>
+        <p:spPr/>
+        <p:txBody>
+          <a:bodyPr/>
+          <a:lstStyle/>
+          <a:p>
+            <a:pPr/>
+            <a:r>
+              <a:rPr lang="th-TH" dirty="0"/>
+              <a:t>โทร · 02-XXX-XXXX</a:t>
+            </a:r>
+          </a:p>
+          <a:p>
+            <a:pPr/>
+            <a:r>
+              <a:rPr lang="th-TH" dirty="0"/>
+              <a:t>อีเมล · contact@nctthai.com</a:t>
+            </a:r>
+          </a:p>
+          <a:p>
+            <a:pPr/>
+            <a:r>
+              <a:rPr lang="th-TH" dirty="0"/>
+              <a:t>เว็บไซต์ · nctthai.com</a:t>
+            </a:r>
+          </a:p>
+        </p:txBody>
+      </p:sp>
+    </p:spTree>
+  </p:cSld>
+  <p:clrMapOvr>
+    <a:masterClrMapping/>
+  </p:clrMapOvr>
+</p:sld>
+</file>
+
 <file path=ppt/slides/slide2.xml><?xml version="1.0" encoding="utf-8"?>
 <p:sld xmlns:a="http://schemas.openxmlformats.org/drawingml/2006/main" xmlns:r="http://schemas.openxmlformats.org/officeDocument/2006/relationships" xmlns:p="http://schemas.openxmlformats.org/presentationml/2006/main">
   <p:cSld name="">

</xml_diff>